<commit_message>
Fig 5D: remove 95% thin ellipse (exceeds panel frame at N=33)
95% confidence ellipse extends past the UMAP axis range because the
small cohort (N=33) inflates the chi-square scaling.  The 68% solid
ellipse plus centroid diamond already conveys group separation; the
thin outer ring added visual clutter without new information.

Panel D now: 85 shapes (was 88).  Legend simplified to
"solid ellipse: 68 % CI".
</commit_message>
<xml_diff>
--- a/260418_add/ppt/Fig5_nested_LASSO_native_editable.pptx
+++ b/260418_add/ppt/Fig5_nested_LASSO_native_editable.pptx
@@ -56369,50 +56369,6 @@
         </p:nvSpPr>
         <p:spPr>
           <a:xfrm rot="10048138">
-            <a:off x="1068970" y="541770"/>
-            <a:ext cx="4127757" cy="2765011"/>
-          </a:xfrm>
-          <a:prstGeom prst="ellipse">
-            <a:avLst/>
-          </a:prstGeom>
-          <a:noFill/>
-          <a:ln w="6350">
-            <a:solidFill>
-              <a:srgbClr val="0A7D6E"/>
-            </a:solidFill>
-          </a:ln>
-          <a:effectLst/>
-        </p:spPr>
-        <p:style>
-          <a:lnRef idx="1">
-            <a:schemeClr val="accent1"/>
-          </a:lnRef>
-          <a:fillRef idx="3">
-            <a:schemeClr val="accent1"/>
-          </a:fillRef>
-          <a:effectRef idx="2">
-            <a:schemeClr val="accent1"/>
-          </a:effectRef>
-          <a:fontRef idx="minor">
-            <a:schemeClr val="lt1"/>
-          </a:fontRef>
-        </p:style>
-        <p:txBody>
-          <a:bodyPr rtlCol="0" anchor="ctr"/>
-          <a:lstStyle/>
-          <a:p>
-            <a:pPr algn="ctr"/>
-          </a:p>
-        </p:txBody>
-      </p:sp>
-      <p:sp>
-        <p:nvSpPr>
-          <p:cNvPr id="28" name="Oval 27"/>
-          <p:cNvSpPr/>
-          <p:nvPr/>
-        </p:nvSpPr>
-        <p:spPr>
-          <a:xfrm rot="10048138">
             <a:off x="1853954" y="1067598"/>
             <a:ext cx="2557789" cy="1713355"/>
           </a:xfrm>
@@ -56451,7 +56407,7 @@
       </p:sp>
       <p:sp>
         <p:nvSpPr>
-          <p:cNvPr id="29" name="Diamond 28"/>
+          <p:cNvPr id="28" name="Diamond 27"/>
           <p:cNvSpPr/>
           <p:nvPr/>
         </p:nvSpPr>
@@ -56497,51 +56453,7 @@
       </p:sp>
       <p:sp>
         <p:nvSpPr>
-          <p:cNvPr id="30" name="Oval 29"/>
-          <p:cNvSpPr/>
-          <p:nvPr/>
-        </p:nvSpPr>
-        <p:spPr>
-          <a:xfrm rot="11408180">
-            <a:off x="487877" y="1199066"/>
-            <a:ext cx="4594039" cy="1850658"/>
-          </a:xfrm>
-          <a:prstGeom prst="ellipse">
-            <a:avLst/>
-          </a:prstGeom>
-          <a:noFill/>
-          <a:ln w="6350">
-            <a:solidFill>
-              <a:srgbClr val="C53E1F"/>
-            </a:solidFill>
-          </a:ln>
-          <a:effectLst/>
-        </p:spPr>
-        <p:style>
-          <a:lnRef idx="1">
-            <a:schemeClr val="accent1"/>
-          </a:lnRef>
-          <a:fillRef idx="3">
-            <a:schemeClr val="accent1"/>
-          </a:fillRef>
-          <a:effectRef idx="2">
-            <a:schemeClr val="accent1"/>
-          </a:effectRef>
-          <a:fontRef idx="minor">
-            <a:schemeClr val="lt1"/>
-          </a:fontRef>
-        </p:style>
-        <p:txBody>
-          <a:bodyPr rtlCol="0" anchor="ctr"/>
-          <a:lstStyle/>
-          <a:p>
-            <a:pPr algn="ctr"/>
-          </a:p>
-        </p:txBody>
-      </p:sp>
-      <p:sp>
-        <p:nvSpPr>
-          <p:cNvPr id="31" name="Oval 30"/>
+          <p:cNvPr id="29" name="Oval 28"/>
           <p:cNvSpPr/>
           <p:nvPr/>
         </p:nvSpPr>
@@ -56585,7 +56497,7 @@
       </p:sp>
       <p:sp>
         <p:nvSpPr>
-          <p:cNvPr id="32" name="Diamond 31"/>
+          <p:cNvPr id="30" name="Diamond 29"/>
           <p:cNvSpPr/>
           <p:nvPr/>
         </p:nvSpPr>
@@ -56631,7 +56543,7 @@
       </p:sp>
       <p:sp>
         <p:nvSpPr>
-          <p:cNvPr id="33" name="Oval 32"/>
+          <p:cNvPr id="31" name="Oval 30"/>
           <p:cNvSpPr/>
           <p:nvPr/>
         </p:nvSpPr>
@@ -56677,7 +56589,7 @@
       </p:sp>
       <p:sp>
         <p:nvSpPr>
-          <p:cNvPr id="34" name="TextBox 33"/>
+          <p:cNvPr id="32" name="TextBox 31"/>
           <p:cNvSpPr txBox="1"/>
           <p:nvPr/>
         </p:nvSpPr>
@@ -56713,7 +56625,7 @@
       </p:sp>
       <p:sp>
         <p:nvSpPr>
-          <p:cNvPr id="35" name="Oval 34"/>
+          <p:cNvPr id="33" name="Oval 32"/>
           <p:cNvSpPr/>
           <p:nvPr/>
         </p:nvSpPr>
@@ -56759,7 +56671,7 @@
       </p:sp>
       <p:sp>
         <p:nvSpPr>
-          <p:cNvPr id="36" name="Oval 35"/>
+          <p:cNvPr id="34" name="Oval 33"/>
           <p:cNvSpPr/>
           <p:nvPr/>
         </p:nvSpPr>
@@ -56805,7 +56717,7 @@
       </p:sp>
       <p:sp>
         <p:nvSpPr>
-          <p:cNvPr id="37" name="Oval 36"/>
+          <p:cNvPr id="35" name="Oval 34"/>
           <p:cNvSpPr/>
           <p:nvPr/>
         </p:nvSpPr>
@@ -56851,7 +56763,7 @@
       </p:sp>
       <p:sp>
         <p:nvSpPr>
-          <p:cNvPr id="38" name="Oval 37"/>
+          <p:cNvPr id="36" name="Oval 35"/>
           <p:cNvSpPr/>
           <p:nvPr/>
         </p:nvSpPr>
@@ -56897,7 +56809,7 @@
       </p:sp>
       <p:sp>
         <p:nvSpPr>
-          <p:cNvPr id="39" name="TextBox 38"/>
+          <p:cNvPr id="37" name="TextBox 36"/>
           <p:cNvSpPr txBox="1"/>
           <p:nvPr/>
         </p:nvSpPr>
@@ -56933,7 +56845,7 @@
       </p:sp>
       <p:sp>
         <p:nvSpPr>
-          <p:cNvPr id="40" name="Oval 39"/>
+          <p:cNvPr id="38" name="Oval 37"/>
           <p:cNvSpPr/>
           <p:nvPr/>
         </p:nvSpPr>
@@ -56979,7 +56891,7 @@
       </p:sp>
       <p:sp>
         <p:nvSpPr>
-          <p:cNvPr id="41" name="Oval 40"/>
+          <p:cNvPr id="39" name="Oval 38"/>
           <p:cNvSpPr/>
           <p:nvPr/>
         </p:nvSpPr>
@@ -57025,7 +56937,7 @@
       </p:sp>
       <p:sp>
         <p:nvSpPr>
-          <p:cNvPr id="42" name="TextBox 41"/>
+          <p:cNvPr id="40" name="TextBox 39"/>
           <p:cNvSpPr txBox="1"/>
           <p:nvPr/>
         </p:nvSpPr>
@@ -57061,7 +56973,7 @@
       </p:sp>
       <p:sp>
         <p:nvSpPr>
-          <p:cNvPr id="43" name="Oval 42"/>
+          <p:cNvPr id="41" name="Oval 40"/>
           <p:cNvSpPr/>
           <p:nvPr/>
         </p:nvSpPr>
@@ -57107,7 +57019,7 @@
       </p:sp>
       <p:sp>
         <p:nvSpPr>
-          <p:cNvPr id="44" name="TextBox 43"/>
+          <p:cNvPr id="42" name="TextBox 41"/>
           <p:cNvSpPr txBox="1"/>
           <p:nvPr/>
         </p:nvSpPr>
@@ -57143,7 +57055,7 @@
       </p:sp>
       <p:sp>
         <p:nvSpPr>
-          <p:cNvPr id="45" name="Oval 44"/>
+          <p:cNvPr id="43" name="Oval 42"/>
           <p:cNvSpPr/>
           <p:nvPr/>
         </p:nvSpPr>
@@ -57189,7 +57101,7 @@
       </p:sp>
       <p:sp>
         <p:nvSpPr>
-          <p:cNvPr id="46" name="Oval 45"/>
+          <p:cNvPr id="44" name="Oval 43"/>
           <p:cNvSpPr/>
           <p:nvPr/>
         </p:nvSpPr>
@@ -57235,7 +57147,7 @@
       </p:sp>
       <p:sp>
         <p:nvSpPr>
-          <p:cNvPr id="47" name="TextBox 46"/>
+          <p:cNvPr id="45" name="TextBox 44"/>
           <p:cNvSpPr txBox="1"/>
           <p:nvPr/>
         </p:nvSpPr>
@@ -57271,7 +57183,7 @@
       </p:sp>
       <p:sp>
         <p:nvSpPr>
-          <p:cNvPr id="48" name="Oval 47"/>
+          <p:cNvPr id="46" name="Oval 45"/>
           <p:cNvSpPr/>
           <p:nvPr/>
         </p:nvSpPr>
@@ -57317,7 +57229,7 @@
       </p:sp>
       <p:sp>
         <p:nvSpPr>
-          <p:cNvPr id="49" name="TextBox 48"/>
+          <p:cNvPr id="47" name="TextBox 46"/>
           <p:cNvSpPr txBox="1"/>
           <p:nvPr/>
         </p:nvSpPr>
@@ -57353,7 +57265,7 @@
       </p:sp>
       <p:sp>
         <p:nvSpPr>
-          <p:cNvPr id="50" name="Oval 49"/>
+          <p:cNvPr id="48" name="Oval 47"/>
           <p:cNvSpPr/>
           <p:nvPr/>
         </p:nvSpPr>
@@ -57399,7 +57311,7 @@
       </p:sp>
       <p:sp>
         <p:nvSpPr>
-          <p:cNvPr id="51" name="TextBox 50"/>
+          <p:cNvPr id="49" name="TextBox 48"/>
           <p:cNvSpPr txBox="1"/>
           <p:nvPr/>
         </p:nvSpPr>
@@ -57435,7 +57347,7 @@
       </p:sp>
       <p:sp>
         <p:nvSpPr>
-          <p:cNvPr id="52" name="Oval 51"/>
+          <p:cNvPr id="50" name="Oval 49"/>
           <p:cNvSpPr/>
           <p:nvPr/>
         </p:nvSpPr>
@@ -57481,7 +57393,7 @@
       </p:sp>
       <p:sp>
         <p:nvSpPr>
-          <p:cNvPr id="53" name="Oval 52"/>
+          <p:cNvPr id="51" name="Oval 50"/>
           <p:cNvSpPr/>
           <p:nvPr/>
         </p:nvSpPr>
@@ -57527,7 +57439,7 @@
       </p:sp>
       <p:sp>
         <p:nvSpPr>
-          <p:cNvPr id="54" name="Oval 53"/>
+          <p:cNvPr id="52" name="Oval 51"/>
           <p:cNvSpPr/>
           <p:nvPr/>
         </p:nvSpPr>
@@ -57573,7 +57485,7 @@
       </p:sp>
       <p:sp>
         <p:nvSpPr>
-          <p:cNvPr id="55" name="Oval 54"/>
+          <p:cNvPr id="53" name="Oval 52"/>
           <p:cNvSpPr/>
           <p:nvPr/>
         </p:nvSpPr>
@@ -57619,7 +57531,7 @@
       </p:sp>
       <p:sp>
         <p:nvSpPr>
-          <p:cNvPr id="56" name="TextBox 55"/>
+          <p:cNvPr id="54" name="TextBox 53"/>
           <p:cNvSpPr txBox="1"/>
           <p:nvPr/>
         </p:nvSpPr>
@@ -57655,7 +57567,7 @@
       </p:sp>
       <p:sp>
         <p:nvSpPr>
-          <p:cNvPr id="57" name="Oval 56"/>
+          <p:cNvPr id="55" name="Oval 54"/>
           <p:cNvSpPr/>
           <p:nvPr/>
         </p:nvSpPr>
@@ -57701,7 +57613,7 @@
       </p:sp>
       <p:sp>
         <p:nvSpPr>
-          <p:cNvPr id="58" name="TextBox 57"/>
+          <p:cNvPr id="56" name="TextBox 55"/>
           <p:cNvSpPr txBox="1"/>
           <p:nvPr/>
         </p:nvSpPr>
@@ -57737,7 +57649,7 @@
       </p:sp>
       <p:sp>
         <p:nvSpPr>
-          <p:cNvPr id="59" name="Oval 58"/>
+          <p:cNvPr id="57" name="Oval 56"/>
           <p:cNvSpPr/>
           <p:nvPr/>
         </p:nvSpPr>
@@ -57783,7 +57695,7 @@
       </p:sp>
       <p:sp>
         <p:nvSpPr>
-          <p:cNvPr id="60" name="Oval 59"/>
+          <p:cNvPr id="58" name="Oval 57"/>
           <p:cNvSpPr/>
           <p:nvPr/>
         </p:nvSpPr>
@@ -57829,7 +57741,7 @@
       </p:sp>
       <p:sp>
         <p:nvSpPr>
-          <p:cNvPr id="61" name="Oval 60"/>
+          <p:cNvPr id="59" name="Oval 58"/>
           <p:cNvSpPr/>
           <p:nvPr/>
         </p:nvSpPr>
@@ -57875,7 +57787,7 @@
       </p:sp>
       <p:sp>
         <p:nvSpPr>
-          <p:cNvPr id="62" name="Oval 61"/>
+          <p:cNvPr id="60" name="Oval 59"/>
           <p:cNvSpPr/>
           <p:nvPr/>
         </p:nvSpPr>
@@ -57921,7 +57833,7 @@
       </p:sp>
       <p:sp>
         <p:nvSpPr>
-          <p:cNvPr id="63" name="TextBox 62"/>
+          <p:cNvPr id="61" name="TextBox 60"/>
           <p:cNvSpPr txBox="1"/>
           <p:nvPr/>
         </p:nvSpPr>
@@ -57957,7 +57869,7 @@
       </p:sp>
       <p:sp>
         <p:nvSpPr>
-          <p:cNvPr id="64" name="Oval 63"/>
+          <p:cNvPr id="62" name="Oval 61"/>
           <p:cNvSpPr/>
           <p:nvPr/>
         </p:nvSpPr>
@@ -58003,7 +57915,7 @@
       </p:sp>
       <p:sp>
         <p:nvSpPr>
-          <p:cNvPr id="65" name="Oval 64"/>
+          <p:cNvPr id="63" name="Oval 62"/>
           <p:cNvSpPr/>
           <p:nvPr/>
         </p:nvSpPr>
@@ -58049,7 +57961,7 @@
       </p:sp>
       <p:sp>
         <p:nvSpPr>
-          <p:cNvPr id="66" name="TextBox 65"/>
+          <p:cNvPr id="64" name="TextBox 63"/>
           <p:cNvSpPr txBox="1"/>
           <p:nvPr/>
         </p:nvSpPr>
@@ -58085,7 +57997,7 @@
       </p:sp>
       <p:sp>
         <p:nvSpPr>
-          <p:cNvPr id="67" name="Oval 66"/>
+          <p:cNvPr id="65" name="Oval 64"/>
           <p:cNvSpPr/>
           <p:nvPr/>
         </p:nvSpPr>
@@ -58131,7 +58043,7 @@
       </p:sp>
       <p:sp>
         <p:nvSpPr>
-          <p:cNvPr id="68" name="Oval 67"/>
+          <p:cNvPr id="66" name="Oval 65"/>
           <p:cNvSpPr/>
           <p:nvPr/>
         </p:nvSpPr>
@@ -58177,7 +58089,7 @@
       </p:sp>
       <p:sp>
         <p:nvSpPr>
-          <p:cNvPr id="69" name="TextBox 68"/>
+          <p:cNvPr id="67" name="TextBox 66"/>
           <p:cNvSpPr txBox="1"/>
           <p:nvPr/>
         </p:nvSpPr>
@@ -58213,7 +58125,7 @@
       </p:sp>
       <p:sp>
         <p:nvSpPr>
-          <p:cNvPr id="70" name="Oval 69"/>
+          <p:cNvPr id="68" name="Oval 67"/>
           <p:cNvSpPr/>
           <p:nvPr/>
         </p:nvSpPr>
@@ -58259,7 +58171,7 @@
       </p:sp>
       <p:sp>
         <p:nvSpPr>
-          <p:cNvPr id="71" name="TextBox 70"/>
+          <p:cNvPr id="69" name="TextBox 68"/>
           <p:cNvSpPr txBox="1"/>
           <p:nvPr/>
         </p:nvSpPr>
@@ -58295,7 +58207,7 @@
       </p:sp>
       <p:sp>
         <p:nvSpPr>
-          <p:cNvPr id="72" name="Oval 71"/>
+          <p:cNvPr id="70" name="Oval 69"/>
           <p:cNvSpPr/>
           <p:nvPr/>
         </p:nvSpPr>
@@ -58341,7 +58253,7 @@
       </p:sp>
       <p:sp>
         <p:nvSpPr>
-          <p:cNvPr id="73" name="Oval 72"/>
+          <p:cNvPr id="71" name="Oval 70"/>
           <p:cNvSpPr/>
           <p:nvPr/>
         </p:nvSpPr>
@@ -58387,7 +58299,7 @@
       </p:sp>
       <p:sp>
         <p:nvSpPr>
-          <p:cNvPr id="74" name="Oval 73"/>
+          <p:cNvPr id="72" name="Oval 71"/>
           <p:cNvSpPr/>
           <p:nvPr/>
         </p:nvSpPr>
@@ -58433,7 +58345,7 @@
       </p:sp>
       <p:sp>
         <p:nvSpPr>
-          <p:cNvPr id="75" name="Oval 74"/>
+          <p:cNvPr id="73" name="Oval 72"/>
           <p:cNvSpPr/>
           <p:nvPr/>
         </p:nvSpPr>
@@ -58479,7 +58391,7 @@
       </p:sp>
       <p:sp>
         <p:nvSpPr>
-          <p:cNvPr id="76" name="Oval 75"/>
+          <p:cNvPr id="74" name="Oval 73"/>
           <p:cNvSpPr/>
           <p:nvPr/>
         </p:nvSpPr>
@@ -58525,7 +58437,7 @@
       </p:sp>
       <p:sp>
         <p:nvSpPr>
-          <p:cNvPr id="77" name="Oval 76"/>
+          <p:cNvPr id="75" name="Oval 74"/>
           <p:cNvSpPr/>
           <p:nvPr/>
         </p:nvSpPr>
@@ -58571,7 +58483,7 @@
       </p:sp>
       <p:sp>
         <p:nvSpPr>
-          <p:cNvPr id="78" name="Oval 77"/>
+          <p:cNvPr id="76" name="Oval 75"/>
           <p:cNvSpPr/>
           <p:nvPr/>
         </p:nvSpPr>
@@ -58617,7 +58529,7 @@
       </p:sp>
       <p:sp>
         <p:nvSpPr>
-          <p:cNvPr id="79" name="TextBox 78"/>
+          <p:cNvPr id="77" name="TextBox 76"/>
           <p:cNvSpPr txBox="1"/>
           <p:nvPr/>
         </p:nvSpPr>
@@ -58653,7 +58565,7 @@
       </p:sp>
       <p:sp>
         <p:nvSpPr>
-          <p:cNvPr id="80" name="Oval 79"/>
+          <p:cNvPr id="78" name="Oval 77"/>
           <p:cNvSpPr/>
           <p:nvPr/>
         </p:nvSpPr>
@@ -58699,7 +58611,7 @@
       </p:sp>
       <p:sp>
         <p:nvSpPr>
-          <p:cNvPr id="81" name="Oval 80"/>
+          <p:cNvPr id="79" name="Oval 78"/>
           <p:cNvSpPr/>
           <p:nvPr/>
         </p:nvSpPr>
@@ -58745,7 +58657,7 @@
       </p:sp>
       <p:sp>
         <p:nvSpPr>
-          <p:cNvPr id="82" name="Oval 81"/>
+          <p:cNvPr id="80" name="Oval 79"/>
           <p:cNvSpPr/>
           <p:nvPr/>
         </p:nvSpPr>
@@ -58791,7 +58703,7 @@
       </p:sp>
       <p:sp>
         <p:nvSpPr>
-          <p:cNvPr id="83" name="TextBox 82"/>
+          <p:cNvPr id="81" name="TextBox 80"/>
           <p:cNvSpPr txBox="1"/>
           <p:nvPr/>
         </p:nvSpPr>
@@ -58827,7 +58739,7 @@
       </p:sp>
       <p:sp>
         <p:nvSpPr>
-          <p:cNvPr id="84" name="Oval 83"/>
+          <p:cNvPr id="82" name="Oval 81"/>
           <p:cNvSpPr/>
           <p:nvPr/>
         </p:nvSpPr>
@@ -58873,7 +58785,7 @@
       </p:sp>
       <p:sp>
         <p:nvSpPr>
-          <p:cNvPr id="85" name="TextBox 84"/>
+          <p:cNvPr id="83" name="TextBox 82"/>
           <p:cNvSpPr txBox="1"/>
           <p:nvPr/>
         </p:nvSpPr>
@@ -58909,7 +58821,7 @@
       </p:sp>
       <p:sp>
         <p:nvSpPr>
-          <p:cNvPr id="86" name="Oval 85"/>
+          <p:cNvPr id="84" name="Oval 83"/>
           <p:cNvSpPr/>
           <p:nvPr/>
         </p:nvSpPr>
@@ -58955,7 +58867,7 @@
       </p:sp>
       <p:sp>
         <p:nvSpPr>
-          <p:cNvPr id="87" name="TextBox 86"/>
+          <p:cNvPr id="85" name="TextBox 84"/>
           <p:cNvSpPr txBox="1"/>
           <p:nvPr/>
         </p:nvSpPr>
@@ -58991,7 +58903,7 @@
       </p:sp>
       <p:sp>
         <p:nvSpPr>
-          <p:cNvPr id="88" name="TextBox 87"/>
+          <p:cNvPr id="86" name="TextBox 85"/>
           <p:cNvSpPr txBox="1"/>
           <p:nvPr/>
         </p:nvSpPr>
@@ -59021,42 +58933,6 @@
                 <a:latin typeface="Arial"/>
               </a:rPr>
               <a:t>solid ellipse: 68 % CI</a:t>
-            </a:r>
-          </a:p>
-        </p:txBody>
-      </p:sp>
-      <p:sp>
-        <p:nvSpPr>
-          <p:cNvPr id="89" name="TextBox 88"/>
-          <p:cNvSpPr txBox="1"/>
-          <p:nvPr/>
-        </p:nvSpPr>
-        <p:spPr>
-          <a:xfrm>
-            <a:off x="3840480" y="1307592"/>
-            <a:ext cx="1554480" cy="137160"/>
-          </a:xfrm>
-          <a:prstGeom prst="rect">
-            <a:avLst/>
-          </a:prstGeom>
-          <a:noFill/>
-          <a:effectLst/>
-        </p:spPr>
-        <p:txBody>
-          <a:bodyPr wrap="square" lIns="0" rIns="0" tIns="0" bIns="0" anchor="ctr">
-            <a:spAutoFit/>
-          </a:bodyPr>
-          <a:lstStyle/>
-          <a:p>
-            <a:pPr algn="l"/>
-            <a:r>
-              <a:rPr sz="600" b="0" i="0">
-                <a:solidFill>
-                  <a:srgbClr val="555555"/>
-                </a:solidFill>
-                <a:latin typeface="Arial"/>
-              </a:rPr>
-              <a:t>thin ellipse: 95 % CI</a:t>
             </a:r>
           </a:p>
         </p:txBody>

</xml_diff>

<commit_message>
Fig 5B: distinguish CI ribbon (grey) from AUC fill (teal)
Previously SHADE (#C8DED8, CI ribbon) and AUC_FILL (#C5DFD7, AUC
area) differed by ~3 RGB units and were indistinguishable on screen.
The two regions encode different information:

  - 95% bootstrap CI ribbon  -> uncertainty
  - Area under ROC (above diagonal) -> discriminative power

Split the palette:
  - SHADE    #D8DCE2  neutral light grey   (CI ribbon)
  - AUC_FILL #9FC9BE  stronger tint of GOOD (AUC area)

Legend chips now read correctly at a glance.
</commit_message>
<xml_diff>
--- a/260418_add/ppt/Fig5_nested_LASSO_native_editable.pptx
+++ b/260418_add/ppt/Fig5_nested_LASSO_native_editable.pptx
@@ -51336,7 +51336,7 @@
             <a:avLst/>
           </a:prstGeom>
           <a:solidFill>
-            <a:srgbClr val="C8DED8"/>
+            <a:srgbClr val="D8DCE2"/>
           </a:solidFill>
           <a:ln>
             <a:noFill/>
@@ -51380,7 +51380,7 @@
             <a:avLst/>
           </a:prstGeom>
           <a:solidFill>
-            <a:srgbClr val="C8DED8"/>
+            <a:srgbClr val="D8DCE2"/>
           </a:solidFill>
           <a:ln>
             <a:noFill/>
@@ -51424,7 +51424,7 @@
             <a:avLst/>
           </a:prstGeom>
           <a:solidFill>
-            <a:srgbClr val="C8DED8"/>
+            <a:srgbClr val="D8DCE2"/>
           </a:solidFill>
           <a:ln>
             <a:noFill/>
@@ -51468,7 +51468,7 @@
             <a:avLst/>
           </a:prstGeom>
           <a:solidFill>
-            <a:srgbClr val="C8DED8"/>
+            <a:srgbClr val="D8DCE2"/>
           </a:solidFill>
           <a:ln>
             <a:noFill/>
@@ -51512,7 +51512,7 @@
             <a:avLst/>
           </a:prstGeom>
           <a:solidFill>
-            <a:srgbClr val="C8DED8"/>
+            <a:srgbClr val="D8DCE2"/>
           </a:solidFill>
           <a:ln>
             <a:noFill/>
@@ -51556,7 +51556,7 @@
             <a:avLst/>
           </a:prstGeom>
           <a:solidFill>
-            <a:srgbClr val="C8DED8"/>
+            <a:srgbClr val="D8DCE2"/>
           </a:solidFill>
           <a:ln>
             <a:noFill/>
@@ -51600,7 +51600,7 @@
             <a:avLst/>
           </a:prstGeom>
           <a:solidFill>
-            <a:srgbClr val="C8DED8"/>
+            <a:srgbClr val="D8DCE2"/>
           </a:solidFill>
           <a:ln>
             <a:noFill/>
@@ -51644,7 +51644,7 @@
             <a:avLst/>
           </a:prstGeom>
           <a:solidFill>
-            <a:srgbClr val="C5DFD7"/>
+            <a:srgbClr val="9FC9BE"/>
           </a:solidFill>
           <a:ln>
             <a:noFill/>
@@ -51688,7 +51688,7 @@
             <a:avLst/>
           </a:prstGeom>
           <a:solidFill>
-            <a:srgbClr val="C5DFD7"/>
+            <a:srgbClr val="9FC9BE"/>
           </a:solidFill>
           <a:ln>
             <a:noFill/>
@@ -51732,7 +51732,7 @@
             <a:avLst/>
           </a:prstGeom>
           <a:solidFill>
-            <a:srgbClr val="C5DFD7"/>
+            <a:srgbClr val="9FC9BE"/>
           </a:solidFill>
           <a:ln>
             <a:noFill/>
@@ -51776,7 +51776,7 @@
             <a:avLst/>
           </a:prstGeom>
           <a:solidFill>
-            <a:srgbClr val="C5DFD7"/>
+            <a:srgbClr val="9FC9BE"/>
           </a:solidFill>
           <a:ln>
             <a:noFill/>
@@ -51820,7 +51820,7 @@
             <a:avLst/>
           </a:prstGeom>
           <a:solidFill>
-            <a:srgbClr val="C5DFD7"/>
+            <a:srgbClr val="9FC9BE"/>
           </a:solidFill>
           <a:ln>
             <a:noFill/>
@@ -51864,7 +51864,7 @@
             <a:avLst/>
           </a:prstGeom>
           <a:solidFill>
-            <a:srgbClr val="C5DFD7"/>
+            <a:srgbClr val="9FC9BE"/>
           </a:solidFill>
           <a:ln>
             <a:noFill/>
@@ -51908,7 +51908,7 @@
             <a:avLst/>
           </a:prstGeom>
           <a:solidFill>
-            <a:srgbClr val="C5DFD7"/>
+            <a:srgbClr val="9FC9BE"/>
           </a:solidFill>
           <a:ln>
             <a:noFill/>
@@ -51952,7 +51952,7 @@
             <a:avLst/>
           </a:prstGeom>
           <a:solidFill>
-            <a:srgbClr val="C5DFD7"/>
+            <a:srgbClr val="9FC9BE"/>
           </a:solidFill>
           <a:ln>
             <a:noFill/>
@@ -53330,7 +53330,7 @@
             <a:avLst/>
           </a:prstGeom>
           <a:solidFill>
-            <a:srgbClr val="C8DED8"/>
+            <a:srgbClr val="D8DCE2"/>
           </a:solidFill>
           <a:ln>
             <a:noFill/>
@@ -53410,7 +53410,7 @@
             <a:avLst/>
           </a:prstGeom>
           <a:solidFill>
-            <a:srgbClr val="C5DFD7"/>
+            <a:srgbClr val="9FC9BE"/>
           </a:solidFill>
           <a:ln>
             <a:noFill/>

</xml_diff>